<commit_message>
feat(defense): SDG intro header -> "ALIGNMENT WITH CAMBODIA'S SDGs"
Now backed by thesis ch2 §2.4 (committed in the supervisor-revision pass,
r20 GREEN on Overleaf). Reverts the 2026-06-17 "CONTRIBUTION TOWARD"
softening, which existed only because the thesis had no SDG section yet.
Presenter notes reconciled to point at §2.4 and keep the honest
alignment / intended-contribution framing (not measured SDG impact).
34 slides, 27/27 tests green; idx5 rendered, header fits one line.

Co-Authored-By: Claude Opus 4.8 <noreply@anthropic.com>
</commit_message>
<xml_diff>
--- a/thesis/health_rl/burgundy_defense_presentation.pptx
+++ b/thesis/health_rl/burgundy_defense_presentation.pptx
@@ -1305,7 +1305,7 @@
           <a:lstStyle/>
           <a:p>
             <a:r>
-              <a:t>Cambodia context: the National Social Security Fund covers only formal-sector workers, roughly 16 percent; private voluntary insurance is nascent and underwriting is mostly manual and rule-based. Actuaries apply fixed premium rules without learning from outcomes, suboptimal decisions compound over a growing applicant pool, and penetration is below 10 percent (2023 estimate). The opportunity: a contextual bandit learns online from each decision while a PSI guardrail watches demographic fairness. This positions the work against Cambodia's Sustainable Development Goals: SDG 3 good health and well-being through wider insurance access, SDG 1 no poverty by shielding households from catastrophic health costs, and SDG 10 reduced inequalities through the PSI fairness guardrail. Frame these as the project's contribution - the report argues them through the penetration gap and fairness monitoring, not as a separate SDG section.</a:t>
+              <a:t>Cambodia context: the National Social Security Fund covers only formal-sector workers, roughly 16 percent; private voluntary insurance is nascent and underwriting is mostly manual and rule-based. Actuaries apply fixed premium rules without learning from outcomes, suboptimal decisions compound over a growing applicant pool, and penetration is below 10 percent (2023 estimate). The opportunity: a contextual bandit learns online from each decision while a PSI guardrail watches demographic fairness. This positions the work against Cambodia's Sustainable Development Goals: SDG 3 good health and well-being through wider insurance access, SDG 1 no poverty by shielding households from catastrophic health costs, and SDG 10 reduced inequalities through the PSI fairness guardrail. The thesis now develops this in a dedicated section - chapter 2 section 2.4, Significance and Alignment with Cambodia's SDGs - which maps the project to SDG 3, 1 and 10. Frame it as the project's intended societal contribution argued through the penetration gap and fairness monitoring; be ready to note this is an alignment argument, not a measured SDG impact.</a:t>
             </a:r>
           </a:p>
         </p:txBody>
@@ -45620,7 +45620,7 @@
             </a:pPr>
             <a:r>
               <a:rPr spc="60"/>
-              <a:t>CONTRIBUTION TOWARD CAMBODIA'S SDGs</a:t>
+              <a:t>ALIGNMENT WITH CAMBODIA'S SDGs</a:t>
             </a:r>
           </a:p>
         </p:txBody>

</xml_diff>